<commit_message>
added caliptra microo ppt
</commit_message>
<xml_diff>
--- a/caliptra microo.pptx
+++ b/caliptra microo.pptx
@@ -3450,7 +3450,7 @@
           <a:lstStyle/>
           <a:p>
             <a:r>
-              <a:rPr lang="en-US" sz="3600">
+              <a:rPr lang="en-US" sz="3200" dirty="0">
                 <a:latin typeface="Calibri" panose="020F0502020204030204" pitchFamily="34" charset="0"/>
                 <a:ea typeface="Calibri" panose="020F0502020204030204" pitchFamily="34" charset="0"/>
                 <a:cs typeface="Calibri" panose="020F0502020204030204" pitchFamily="34" charset="0"/>
@@ -3785,7 +3785,7 @@
           <a:p>
             <a:pPr algn="l"/>
             <a:r>
-              <a:rPr lang="en-US">
+              <a:rPr lang="en-US" dirty="0">
                 <a:solidFill>
                   <a:srgbClr val="FFFFFF"/>
                 </a:solidFill>
@@ -3799,7 +3799,7 @@
           <a:p>
             <a:pPr algn="l"/>
             <a:r>
-              <a:rPr lang="en-US">
+              <a:rPr lang="en-US" dirty="0">
                 <a:solidFill>
                   <a:srgbClr val="FFFFFF"/>
                 </a:solidFill>
@@ -3813,7 +3813,7 @@
           <a:p>
             <a:pPr algn="l"/>
             <a:r>
-              <a:rPr lang="en-US">
+              <a:rPr lang="en-US" dirty="0">
                 <a:solidFill>
                   <a:srgbClr val="FFFFFF"/>
                 </a:solidFill>
@@ -17152,14 +17152,6 @@
 </file>
 
 <file path=customXml/item1.xml><?xml version="1.0" encoding="utf-8"?>
-<p:properties xmlns:p="http://schemas.microsoft.com/office/2006/metadata/properties" xmlns:xsi="http://www.w3.org/2001/XMLSchema-instance" xmlns:pc="http://schemas.microsoft.com/office/infopath/2007/PartnerControls">
-  <documentManagement>
-    <_activity xmlns="ec91e78c-53b9-49d2-80fe-2267c9de2ac1" xsi:nil="true"/>
-  </documentManagement>
-</p:properties>
-</file>
-
-<file path=customXml/item2.xml><?xml version="1.0" encoding="utf-8"?>
 <ct:contentTypeSchema xmlns:ct="http://schemas.microsoft.com/office/2006/metadata/contentType" xmlns:ma="http://schemas.microsoft.com/office/2006/metadata/properties/metaAttributes" ct:_="" ma:_="" ma:contentTypeName="Document" ma:contentTypeID="0x010100F0BB9E5490EEBB438C23297E1D25285B" ma:contentTypeVersion="10" ma:contentTypeDescription="Create a new document." ma:contentTypeScope="" ma:versionID="f1ce0bbb77ae981bb3236c4ff3e5e8c2">
   <xsd:schema xmlns:xsd="http://www.w3.org/2001/XMLSchema" xmlns:xs="http://www.w3.org/2001/XMLSchema" xmlns:p="http://schemas.microsoft.com/office/2006/metadata/properties" xmlns:ns3="ec91e78c-53b9-49d2-80fe-2267c9de2ac1" targetNamespace="http://schemas.microsoft.com/office/2006/metadata/properties" ma:root="true" ma:fieldsID="2211f0910273cfef75d430a4eb610fe0" ns3:_="">
     <xsd:import namespace="ec91e78c-53b9-49d2-80fe-2267c9de2ac1"/>
@@ -17341,6 +17333,14 @@
 </ct:contentTypeSchema>
 </file>
 
+<file path=customXml/item2.xml><?xml version="1.0" encoding="utf-8"?>
+<p:properties xmlns:p="http://schemas.microsoft.com/office/2006/metadata/properties" xmlns:xsi="http://www.w3.org/2001/XMLSchema-instance" xmlns:pc="http://schemas.microsoft.com/office/infopath/2007/PartnerControls">
+  <documentManagement>
+    <_activity xmlns="ec91e78c-53b9-49d2-80fe-2267c9de2ac1" xsi:nil="true"/>
+  </documentManagement>
+</p:properties>
+</file>
+
 <file path=customXml/item3.xml><?xml version="1.0" encoding="utf-8"?>
 <?mso-contentType ?>
 <FormTemplates xmlns="http://schemas.microsoft.com/sharepoint/v3/contenttype/forms">
@@ -17351,22 +17351,6 @@
 </file>
 
 <file path=customXml/itemProps1.xml><?xml version="1.0" encoding="utf-8"?>
-<ds:datastoreItem xmlns:ds="http://schemas.openxmlformats.org/officeDocument/2006/customXml" ds:itemID="{E0C30E90-35A2-433D-8294-0F950042F531}">
-  <ds:schemaRefs>
-    <ds:schemaRef ds:uri="http://www.w3.org/XML/1998/namespace"/>
-    <ds:schemaRef ds:uri="http://purl.org/dc/terms/"/>
-    <ds:schemaRef ds:uri="http://schemas.microsoft.com/office/2006/documentManagement/types"/>
-    <ds:schemaRef ds:uri="ec91e78c-53b9-49d2-80fe-2267c9de2ac1"/>
-    <ds:schemaRef ds:uri="http://purl.org/dc/dcmitype/"/>
-    <ds:schemaRef ds:uri="http://purl.org/dc/elements/1.1/"/>
-    <ds:schemaRef ds:uri="http://schemas.microsoft.com/office/infopath/2007/PartnerControls"/>
-    <ds:schemaRef ds:uri="http://schemas.openxmlformats.org/package/2006/metadata/core-properties"/>
-    <ds:schemaRef ds:uri="http://schemas.microsoft.com/office/2006/metadata/properties"/>
-  </ds:schemaRefs>
-</ds:datastoreItem>
-</file>
-
-<file path=customXml/itemProps2.xml><?xml version="1.0" encoding="utf-8"?>
 <ds:datastoreItem xmlns:ds="http://schemas.openxmlformats.org/officeDocument/2006/customXml" ds:itemID="{C0063AF5-BEA8-4C62-8980-B3BDDFE1EDDD}">
   <ds:schemaRefs>
     <ds:schemaRef ds:uri="ec91e78c-53b9-49d2-80fe-2267c9de2ac1"/>
@@ -17384,6 +17368,22 @@
 </ds:datastoreItem>
 </file>
 
+<file path=customXml/itemProps2.xml><?xml version="1.0" encoding="utf-8"?>
+<ds:datastoreItem xmlns:ds="http://schemas.openxmlformats.org/officeDocument/2006/customXml" ds:itemID="{E0C30E90-35A2-433D-8294-0F950042F531}">
+  <ds:schemaRefs>
+    <ds:schemaRef ds:uri="http://www.w3.org/XML/1998/namespace"/>
+    <ds:schemaRef ds:uri="http://purl.org/dc/terms/"/>
+    <ds:schemaRef ds:uri="http://schemas.microsoft.com/office/2006/documentManagement/types"/>
+    <ds:schemaRef ds:uri="ec91e78c-53b9-49d2-80fe-2267c9de2ac1"/>
+    <ds:schemaRef ds:uri="http://purl.org/dc/dcmitype/"/>
+    <ds:schemaRef ds:uri="http://purl.org/dc/elements/1.1/"/>
+    <ds:schemaRef ds:uri="http://schemas.microsoft.com/office/infopath/2007/PartnerControls"/>
+    <ds:schemaRef ds:uri="http://schemas.openxmlformats.org/package/2006/metadata/core-properties"/>
+    <ds:schemaRef ds:uri="http://schemas.microsoft.com/office/2006/metadata/properties"/>
+  </ds:schemaRefs>
+</ds:datastoreItem>
+</file>
+
 <file path=customXml/itemProps3.xml><?xml version="1.0" encoding="utf-8"?>
 <ds:datastoreItem xmlns:ds="http://schemas.openxmlformats.org/officeDocument/2006/customXml" ds:itemID="{F8666954-3D43-40F3-AF96-B2753E1830EC}">
   <ds:schemaRefs>

</xml_diff>